<commit_message>
Add CPU offload slides
</commit_message>
<xml_diff>
--- a/multi_gpu.pptx
+++ b/multi_gpu.pptx
@@ -5,7 +5,7 @@
     <p:sldMasterId id="2147483660" r:id="rId1"/>
   </p:sldMasterIdLst>
   <p:notesMasterIdLst>
-    <p:notesMasterId r:id="rId11"/>
+    <p:notesMasterId r:id="rId14"/>
   </p:notesMasterIdLst>
   <p:sldIdLst>
     <p:sldId id="257" r:id="rId2"/>
@@ -15,8 +15,11 @@
     <p:sldId id="259" r:id="rId6"/>
     <p:sldId id="787" r:id="rId7"/>
     <p:sldId id="788" r:id="rId8"/>
-    <p:sldId id="769" r:id="rId9"/>
-    <p:sldId id="770" r:id="rId10"/>
+    <p:sldId id="789" r:id="rId9"/>
+    <p:sldId id="790" r:id="rId10"/>
+    <p:sldId id="791" r:id="rId11"/>
+    <p:sldId id="769" r:id="rId12"/>
+    <p:sldId id="770" r:id="rId13"/>
   </p:sldIdLst>
   <p:sldSz cx="12192000" cy="6858000"/>
   <p:notesSz cx="6858000" cy="9144000"/>
@@ -131,6 +134,9 @@
             <p14:sldId id="259"/>
             <p14:sldId id="787"/>
             <p14:sldId id="788"/>
+            <p14:sldId id="789"/>
+            <p14:sldId id="790"/>
+            <p14:sldId id="791"/>
           </p14:sldIdLst>
         </p14:section>
         <p14:section name="Conclusions" id="{A9B2E2E8-EE28-4C08-9F33-76B98F6A83CB}">
@@ -230,7 +236,7 @@
           <a:p>
             <a:fld id="{DBF5F7A3-80FA-4DE8-9E10-D5FD6AAF4E4C}" type="datetimeFigureOut">
               <a:rPr lang="en-US" smtClean="0"/>
-              <a:t>2026-08-18</a:t>
+              <a:t>2026-08-31</a:t>
             </a:fld>
             <a:endParaRPr lang="en-US"/>
           </a:p>
@@ -694,7 +700,7 @@
           <a:p>
             <a:fld id="{12D417FB-DB75-4510-8AD7-5416595AADD8}" type="datetime1">
               <a:rPr lang="en-US" smtClean="0"/>
-              <a:t>2026-08-18</a:t>
+              <a:t>2026-08-31</a:t>
             </a:fld>
             <a:endParaRPr lang="en-US"/>
           </a:p>
@@ -3062,7 +3068,7 @@
           <a:p>
             <a:fld id="{EC448E59-F64F-416B-85C7-F58EA54BAF31}" type="datetime1">
               <a:rPr lang="nl-BE" smtClean="0"/>
-              <a:t>18/08/2026</a:t>
+              <a:t>31/08/2026</a:t>
             </a:fld>
             <a:endParaRPr lang="nl-BE"/>
           </a:p>
@@ -3350,7 +3356,7 @@
           <a:p>
             <a:fld id="{44F0EF99-E673-4972-A23A-EB3FD1F7D254}" type="datetime1">
               <a:rPr lang="nl-BE" smtClean="0"/>
-              <a:t>18/08/2026</a:t>
+              <a:t>31/08/2026</a:t>
             </a:fld>
             <a:endParaRPr lang="nl-BE"/>
           </a:p>
@@ -5401,6 +5407,402 @@
 </p:sld>
 </file>
 
+<file path=ppt/slides/slide10.xml><?xml version="1.0" encoding="utf-8"?>
+<p:sld xmlns:a="http://schemas.openxmlformats.org/drawingml/2006/main" xmlns:r="http://schemas.openxmlformats.org/officeDocument/2006/relationships" xmlns:p="http://schemas.openxmlformats.org/presentationml/2006/main">
+  <p:cSld>
+    <p:spTree>
+      <p:nvGrpSpPr>
+        <p:cNvPr id="1" name=""/>
+        <p:cNvGrpSpPr/>
+        <p:nvPr/>
+      </p:nvGrpSpPr>
+      <p:grpSpPr>
+        <a:xfrm>
+          <a:off x="0" y="0"/>
+          <a:ext cx="0" cy="0"/>
+          <a:chOff x="0" y="0"/>
+          <a:chExt cx="0" cy="0"/>
+        </a:xfrm>
+      </p:grpSpPr>
+      <p:sp>
+        <p:nvSpPr>
+          <p:cNvPr id="2" name="Title 1">
+            <a:extLst>
+              <a:ext uri="{FF2B5EF4-FFF2-40B4-BE49-F238E27FC236}">
+                <a16:creationId xmlns:a16="http://schemas.microsoft.com/office/drawing/2014/main" id="{388F8ACC-A54A-60A0-1997-4ABD0821B09C}"/>
+              </a:ext>
+            </a:extLst>
+          </p:cNvPr>
+          <p:cNvSpPr>
+            <a:spLocks noGrp="1"/>
+          </p:cNvSpPr>
+          <p:nvPr>
+            <p:ph type="title"/>
+          </p:nvPr>
+        </p:nvSpPr>
+        <p:spPr/>
+        <p:txBody>
+          <a:bodyPr/>
+          <a:lstStyle/>
+          <a:p>
+            <a:r>
+              <a:rPr lang="en-US" dirty="0"/>
+              <a:t>Tensor parallelism</a:t>
+            </a:r>
+            <a:endParaRPr lang="LID4096" dirty="0"/>
+          </a:p>
+        </p:txBody>
+      </p:sp>
+      <p:sp>
+        <p:nvSpPr>
+          <p:cNvPr id="3" name="Content Placeholder 2">
+            <a:extLst>
+              <a:ext uri="{FF2B5EF4-FFF2-40B4-BE49-F238E27FC236}">
+                <a16:creationId xmlns:a16="http://schemas.microsoft.com/office/drawing/2014/main" id="{C93B3C2B-3C43-B943-4E3A-41194987120F}"/>
+              </a:ext>
+            </a:extLst>
+          </p:cNvPr>
+          <p:cNvSpPr>
+            <a:spLocks noGrp="1"/>
+          </p:cNvSpPr>
+          <p:nvPr>
+            <p:ph idx="1"/>
+          </p:nvPr>
+        </p:nvSpPr>
+        <p:spPr/>
+        <p:txBody>
+          <a:bodyPr/>
+          <a:lstStyle/>
+          <a:p>
+            <a:endParaRPr lang="LID4096"/>
+          </a:p>
+        </p:txBody>
+      </p:sp>
+      <p:sp>
+        <p:nvSpPr>
+          <p:cNvPr id="4" name="Slide Number Placeholder 3">
+            <a:extLst>
+              <a:ext uri="{FF2B5EF4-FFF2-40B4-BE49-F238E27FC236}">
+                <a16:creationId xmlns:a16="http://schemas.microsoft.com/office/drawing/2014/main" id="{B7C5769C-AD77-1CAA-E79B-F2B2DF4DB165}"/>
+              </a:ext>
+            </a:extLst>
+          </p:cNvPr>
+          <p:cNvSpPr>
+            <a:spLocks noGrp="1"/>
+          </p:cNvSpPr>
+          <p:nvPr>
+            <p:ph type="sldNum" sz="quarter" idx="12"/>
+          </p:nvPr>
+        </p:nvSpPr>
+        <p:spPr/>
+        <p:txBody>
+          <a:bodyPr/>
+          <a:lstStyle/>
+          <a:p>
+            <a:fld id="{5A209D72-2E9D-49B0-8977-41DCCC66C0BB}" type="slidenum">
+              <a:rPr lang="nl-BE" smtClean="0"/>
+              <a:t>10</a:t>
+            </a:fld>
+            <a:endParaRPr lang="nl-BE"/>
+          </a:p>
+        </p:txBody>
+      </p:sp>
+    </p:spTree>
+    <p:extLst>
+      <p:ext uri="{BB962C8B-B14F-4D97-AF65-F5344CB8AC3E}">
+        <p14:creationId xmlns:p14="http://schemas.microsoft.com/office/powerpoint/2010/main" val="503060552"/>
+      </p:ext>
+    </p:extLst>
+  </p:cSld>
+  <p:clrMapOvr>
+    <a:masterClrMapping/>
+  </p:clrMapOvr>
+</p:sld>
+</file>
+
+<file path=ppt/slides/slide11.xml><?xml version="1.0" encoding="utf-8"?>
+<p:sld xmlns:a="http://schemas.openxmlformats.org/drawingml/2006/main" xmlns:r="http://schemas.openxmlformats.org/officeDocument/2006/relationships" xmlns:p="http://schemas.openxmlformats.org/presentationml/2006/main">
+  <p:cSld>
+    <p:spTree>
+      <p:nvGrpSpPr>
+        <p:cNvPr id="1" name=""/>
+        <p:cNvGrpSpPr/>
+        <p:nvPr/>
+      </p:nvGrpSpPr>
+      <p:grpSpPr>
+        <a:xfrm>
+          <a:off x="0" y="0"/>
+          <a:ext cx="0" cy="0"/>
+          <a:chOff x="0" y="0"/>
+          <a:chExt cx="0" cy="0"/>
+        </a:xfrm>
+      </p:grpSpPr>
+      <p:sp>
+        <p:nvSpPr>
+          <p:cNvPr id="2" name="Title 1"/>
+          <p:cNvSpPr>
+            <a:spLocks noGrp="1"/>
+          </p:cNvSpPr>
+          <p:nvPr>
+            <p:ph type="title"/>
+          </p:nvPr>
+        </p:nvSpPr>
+        <p:spPr/>
+        <p:txBody>
+          <a:bodyPr/>
+          <a:lstStyle/>
+          <a:p>
+            <a:r>
+              <a:rPr lang="en-US" dirty="0"/>
+              <a:t>Conclusions</a:t>
+            </a:r>
+          </a:p>
+        </p:txBody>
+      </p:sp>
+      <p:sp>
+        <p:nvSpPr>
+          <p:cNvPr id="3" name="Content Placeholder 2"/>
+          <p:cNvSpPr>
+            <a:spLocks noGrp="1"/>
+          </p:cNvSpPr>
+          <p:nvPr>
+            <p:ph idx="1"/>
+          </p:nvPr>
+        </p:nvSpPr>
+        <p:spPr/>
+        <p:txBody>
+          <a:bodyPr>
+            <a:normAutofit/>
+          </a:bodyPr>
+          <a:lstStyle/>
+          <a:p>
+            <a:r>
+              <a:rPr lang="en-US" dirty="0"/>
+              <a:t>Many things to explore</a:t>
+            </a:r>
+          </a:p>
+          <a:p>
+            <a:endParaRPr lang="en-US" dirty="0"/>
+          </a:p>
+        </p:txBody>
+      </p:sp>
+      <p:sp>
+        <p:nvSpPr>
+          <p:cNvPr id="4" name="Slide Number Placeholder 3"/>
+          <p:cNvSpPr>
+            <a:spLocks noGrp="1"/>
+          </p:cNvSpPr>
+          <p:nvPr>
+            <p:ph type="sldNum" sz="quarter" idx="12"/>
+          </p:nvPr>
+        </p:nvSpPr>
+        <p:spPr/>
+        <p:txBody>
+          <a:bodyPr/>
+          <a:lstStyle/>
+          <a:p>
+            <a:fld id="{5A209D72-2E9D-49B0-8977-41DCCC66C0BB}" type="slidenum">
+              <a:rPr lang="nl-BE" smtClean="0"/>
+              <a:t>11</a:t>
+            </a:fld>
+            <a:endParaRPr lang="nl-BE"/>
+          </a:p>
+        </p:txBody>
+      </p:sp>
+    </p:spTree>
+    <p:extLst>
+      <p:ext uri="{BB962C8B-B14F-4D97-AF65-F5344CB8AC3E}">
+        <p14:creationId xmlns:p14="http://schemas.microsoft.com/office/powerpoint/2010/main" val="1797426774"/>
+      </p:ext>
+    </p:extLst>
+  </p:cSld>
+  <p:clrMapOvr>
+    <a:masterClrMapping/>
+  </p:clrMapOvr>
+  <p:timing>
+    <p:tnLst>
+      <p:par>
+        <p:cTn id="1" dur="indefinite" restart="never" nodeType="tmRoot">
+          <p:childTnLst>
+            <p:seq concurrent="1" nextAc="seek">
+              <p:cTn id="2" dur="indefinite" nodeType="mainSeq">
+                <p:childTnLst>
+                  <p:par>
+                    <p:cTn id="3" fill="hold">
+                      <p:stCondLst>
+                        <p:cond delay="indefinite"/>
+                        <p:cond evt="onBegin" delay="0">
+                          <p:tn val="2"/>
+                        </p:cond>
+                      </p:stCondLst>
+                      <p:childTnLst>
+                        <p:par>
+                          <p:cTn id="4" fill="hold">
+                            <p:stCondLst>
+                              <p:cond delay="0"/>
+                            </p:stCondLst>
+                            <p:childTnLst>
+                              <p:par>
+                                <p:cTn id="5" presetID="1" presetClass="entr" presetSubtype="0" fill="hold" grpId="0" nodeType="withEffect">
+                                  <p:stCondLst>
+                                    <p:cond delay="0"/>
+                                  </p:stCondLst>
+                                  <p:childTnLst>
+                                    <p:set>
+                                      <p:cBhvr>
+                                        <p:cTn id="6" dur="1" fill="hold">
+                                          <p:stCondLst>
+                                            <p:cond delay="0"/>
+                                          </p:stCondLst>
+                                        </p:cTn>
+                                        <p:tgtEl>
+                                          <p:spTgt spid="3">
+                                            <p:txEl>
+                                              <p:pRg st="0" end="0"/>
+                                            </p:txEl>
+                                          </p:spTgt>
+                                        </p:tgtEl>
+                                        <p:attrNameLst>
+                                          <p:attrName>style.visibility</p:attrName>
+                                        </p:attrNameLst>
+                                      </p:cBhvr>
+                                      <p:to>
+                                        <p:strVal val="visible"/>
+                                      </p:to>
+                                    </p:set>
+                                  </p:childTnLst>
+                                </p:cTn>
+                              </p:par>
+                            </p:childTnLst>
+                          </p:cTn>
+                        </p:par>
+                      </p:childTnLst>
+                    </p:cTn>
+                  </p:par>
+                </p:childTnLst>
+              </p:cTn>
+              <p:prevCondLst>
+                <p:cond evt="onPrev" delay="0">
+                  <p:tgtEl>
+                    <p:sldTgt/>
+                  </p:tgtEl>
+                </p:cond>
+              </p:prevCondLst>
+              <p:nextCondLst>
+                <p:cond evt="onNext" delay="0">
+                  <p:tgtEl>
+                    <p:sldTgt/>
+                  </p:tgtEl>
+                </p:cond>
+              </p:nextCondLst>
+            </p:seq>
+          </p:childTnLst>
+        </p:cTn>
+      </p:par>
+    </p:tnLst>
+    <p:bldLst>
+      <p:bldP spid="3" grpId="0" uiExpand="1" build="p"/>
+    </p:bldLst>
+  </p:timing>
+</p:sld>
+</file>
+
+<file path=ppt/slides/slide12.xml><?xml version="1.0" encoding="utf-8"?>
+<p:sld xmlns:a="http://schemas.openxmlformats.org/drawingml/2006/main" xmlns:r="http://schemas.openxmlformats.org/officeDocument/2006/relationships" xmlns:p="http://schemas.openxmlformats.org/presentationml/2006/main">
+  <p:cSld>
+    <p:spTree>
+      <p:nvGrpSpPr>
+        <p:cNvPr id="1" name=""/>
+        <p:cNvGrpSpPr/>
+        <p:nvPr/>
+      </p:nvGrpSpPr>
+      <p:grpSpPr>
+        <a:xfrm>
+          <a:off x="0" y="0"/>
+          <a:ext cx="0" cy="0"/>
+          <a:chOff x="0" y="0"/>
+          <a:chExt cx="0" cy="0"/>
+        </a:xfrm>
+      </p:grpSpPr>
+      <p:sp>
+        <p:nvSpPr>
+          <p:cNvPr id="2" name="Title 1"/>
+          <p:cNvSpPr>
+            <a:spLocks noGrp="1"/>
+          </p:cNvSpPr>
+          <p:nvPr>
+            <p:ph type="title"/>
+          </p:nvPr>
+        </p:nvSpPr>
+        <p:spPr/>
+        <p:txBody>
+          <a:bodyPr/>
+          <a:lstStyle/>
+          <a:p>
+            <a:r>
+              <a:rPr lang="en-US" dirty="0"/>
+              <a:t>Further reading</a:t>
+            </a:r>
+          </a:p>
+        </p:txBody>
+      </p:sp>
+      <p:sp>
+        <p:nvSpPr>
+          <p:cNvPr id="3" name="Content Placeholder 2"/>
+          <p:cNvSpPr>
+            <a:spLocks noGrp="1"/>
+          </p:cNvSpPr>
+          <p:nvPr>
+            <p:ph idx="1"/>
+          </p:nvPr>
+        </p:nvSpPr>
+        <p:spPr/>
+        <p:txBody>
+          <a:bodyPr>
+            <a:normAutofit/>
+          </a:bodyPr>
+          <a:lstStyle/>
+          <a:p>
+            <a:endParaRPr lang="" dirty="0"/>
+          </a:p>
+        </p:txBody>
+      </p:sp>
+      <p:sp>
+        <p:nvSpPr>
+          <p:cNvPr id="4" name="Slide Number Placeholder 3"/>
+          <p:cNvSpPr>
+            <a:spLocks noGrp="1"/>
+          </p:cNvSpPr>
+          <p:nvPr>
+            <p:ph type="sldNum" sz="quarter" idx="12"/>
+          </p:nvPr>
+        </p:nvSpPr>
+        <p:spPr/>
+        <p:txBody>
+          <a:bodyPr/>
+          <a:lstStyle/>
+          <a:p>
+            <a:fld id="{5A209D72-2E9D-49B0-8977-41DCCC66C0BB}" type="slidenum">
+              <a:rPr lang="nl-BE" smtClean="0"/>
+              <a:t>12</a:t>
+            </a:fld>
+            <a:endParaRPr lang="nl-BE"/>
+          </a:p>
+        </p:txBody>
+      </p:sp>
+    </p:spTree>
+    <p:extLst>
+      <p:ext uri="{BB962C8B-B14F-4D97-AF65-F5344CB8AC3E}">
+        <p14:creationId xmlns:p14="http://schemas.microsoft.com/office/powerpoint/2010/main" val="3443787918"/>
+      </p:ext>
+    </p:extLst>
+  </p:cSld>
+  <p:clrMapOvr>
+    <a:masterClrMapping/>
+  </p:clrMapOvr>
+</p:sld>
+</file>
+
 <file path=ppt/slides/slide2.xml><?xml version="1.0" encoding="utf-8"?>
 <p:sld xmlns:a="http://schemas.openxmlformats.org/drawingml/2006/main" xmlns:r="http://schemas.openxmlformats.org/officeDocument/2006/relationships" xmlns:p="http://schemas.openxmlformats.org/presentationml/2006/main">
   <p:cSld>
@@ -5679,7 +6081,7 @@
           <a:p>
             <a:r>
               <a:rPr lang="en-US" dirty="0"/>
-              <a:t> Evolution</a:t>
+              <a:t> Technical evolution</a:t>
             </a:r>
           </a:p>
           <a:p>
@@ -9327,6 +9729,12 @@
           <a:p>
             <a:r>
               <a:rPr lang="en-US" dirty="0"/>
+              <a:t>Fully Sharded Data Parallelism</a:t>
+            </a:r>
+          </a:p>
+          <a:p>
+            <a:r>
+              <a:rPr lang="en-US" dirty="0"/>
               <a:t>Layer-wise model parallelism</a:t>
             </a:r>
           </a:p>
@@ -9406,7 +9814,13 @@
       </p:grpSpPr>
       <p:sp>
         <p:nvSpPr>
-          <p:cNvPr id="2" name="Title 1"/>
+          <p:cNvPr id="2" name="Title 1">
+            <a:extLst>
+              <a:ext uri="{FF2B5EF4-FFF2-40B4-BE49-F238E27FC236}">
+                <a16:creationId xmlns:a16="http://schemas.microsoft.com/office/drawing/2014/main" id="{31540FD3-7881-9DE7-A602-CC751C03F50B}"/>
+              </a:ext>
+            </a:extLst>
+          </p:cNvPr>
           <p:cNvSpPr>
             <a:spLocks noGrp="1"/>
           </p:cNvSpPr>
@@ -9421,14 +9835,21 @@
           <a:p>
             <a:r>
               <a:rPr lang="en-US" dirty="0"/>
-              <a:t>Conclusions</a:t>
-            </a:r>
-          </a:p>
-        </p:txBody>
-      </p:sp>
-      <p:sp>
-        <p:nvSpPr>
-          <p:cNvPr id="3" name="Content Placeholder 2"/>
+              <a:t>CPU offload</a:t>
+            </a:r>
+            <a:endParaRPr lang="LID4096" dirty="0"/>
+          </a:p>
+        </p:txBody>
+      </p:sp>
+      <p:sp>
+        <p:nvSpPr>
+          <p:cNvPr id="3" name="Content Placeholder 2">
+            <a:extLst>
+              <a:ext uri="{FF2B5EF4-FFF2-40B4-BE49-F238E27FC236}">
+                <a16:creationId xmlns:a16="http://schemas.microsoft.com/office/drawing/2014/main" id="{74A67A10-35A2-36DE-24FF-8A3C2F609EAD}"/>
+              </a:ext>
+            </a:extLst>
+          </p:cNvPr>
           <p:cNvSpPr>
             <a:spLocks noGrp="1"/>
           </p:cNvSpPr>
@@ -9438,24 +9859,95 @@
         </p:nvSpPr>
         <p:spPr/>
         <p:txBody>
-          <a:bodyPr>
-            <a:normAutofit/>
-          </a:bodyPr>
+          <a:bodyPr/>
           <a:lstStyle/>
           <a:p>
             <a:r>
               <a:rPr lang="en-US" dirty="0"/>
-              <a:t>Many things to explore</a:t>
-            </a:r>
-          </a:p>
-          <a:p>
+              <a:t>Training:</a:t>
+            </a:r>
+          </a:p>
+          <a:p>
+            <a:pPr lvl="1"/>
+            <a:r>
+              <a:rPr lang="en-US" dirty="0"/>
+              <a:t>1 GPU, model + state don't fit</a:t>
+            </a:r>
+          </a:p>
+          <a:p>
+            <a:pPr lvl="1"/>
+            <a:r>
+              <a:rPr lang="en-US" dirty="0"/>
+              <a:t>Offload to CPU</a:t>
+            </a:r>
+          </a:p>
+          <a:p>
+            <a:pPr lvl="2"/>
+            <a:r>
+              <a:rPr lang="en-US" dirty="0"/>
+              <a:t>Optimizer state: optimizer on CPU</a:t>
+            </a:r>
+          </a:p>
+          <a:p>
+            <a:pPr lvl="2"/>
+            <a:r>
+              <a:rPr lang="en-US" dirty="0"/>
+              <a:t>Parameters &amp; gradients: optimizer on CPU</a:t>
+            </a:r>
+          </a:p>
+          <a:p>
+            <a:r>
+              <a:rPr lang="en-US" dirty="0"/>
+              <a:t>Inference</a:t>
+            </a:r>
+          </a:p>
+          <a:p>
+            <a:pPr lvl="1"/>
+            <a:r>
+              <a:rPr lang="en-US" dirty="0"/>
+              <a:t>1 GPU, model doesn't fit</a:t>
+            </a:r>
+          </a:p>
+          <a:p>
+            <a:pPr lvl="1"/>
+            <a:r>
+              <a:rPr lang="en-US" dirty="0"/>
+              <a:t>Offload to CPU: parameters (layers)</a:t>
+            </a:r>
+          </a:p>
+          <a:p>
+            <a:pPr lvl="2"/>
+            <a:r>
+              <a:rPr lang="en-US" dirty="0"/>
+              <a:t>Evaluated on GPU: compute performance    , I/O</a:t>
+            </a:r>
+          </a:p>
+          <a:p>
+            <a:pPr lvl="2"/>
+            <a:r>
+              <a:rPr lang="en-US" dirty="0"/>
+              <a:t>Evaluated on CPU: compute performance     , I/O</a:t>
+            </a:r>
+          </a:p>
+          <a:p>
+            <a:pPr lvl="1"/>
             <a:endParaRPr lang="en-US" dirty="0"/>
           </a:p>
-        </p:txBody>
-      </p:sp>
-      <p:sp>
-        <p:nvSpPr>
-          <p:cNvPr id="4" name="Slide Number Placeholder 3"/>
+          <a:p>
+            <a:pPr lvl="1"/>
+            <a:endParaRPr lang="LID4096" dirty="0"/>
+          </a:p>
+        </p:txBody>
+      </p:sp>
+      <p:sp>
+        <p:nvSpPr>
+          <p:cNvPr id="4" name="Slide Number Placeholder 3">
+            <a:extLst>
+              <a:ext uri="{FF2B5EF4-FFF2-40B4-BE49-F238E27FC236}">
+                <a16:creationId xmlns:a16="http://schemas.microsoft.com/office/drawing/2014/main" id="{814E1FF9-E20A-378B-20F6-6AE53BE4419B}"/>
+              </a:ext>
+            </a:extLst>
+          </p:cNvPr>
           <p:cNvSpPr>
             <a:spLocks noGrp="1"/>
           </p:cNvSpPr>
@@ -9476,101 +9968,160 @@
           </a:p>
         </p:txBody>
       </p:sp>
+      <p:pic>
+        <p:nvPicPr>
+          <p:cNvPr id="6" name="Graphic 5" descr="Rocket with solid fill">
+            <a:extLst>
+              <a:ext uri="{FF2B5EF4-FFF2-40B4-BE49-F238E27FC236}">
+                <a16:creationId xmlns:a16="http://schemas.microsoft.com/office/drawing/2014/main" id="{A977C548-FD0D-942F-3EBF-7F638117ED37}"/>
+              </a:ext>
+            </a:extLst>
+          </p:cNvPr>
+          <p:cNvPicPr>
+            <a:picLocks noChangeAspect="1"/>
+          </p:cNvPicPr>
+          <p:nvPr/>
+        </p:nvPicPr>
+        <p:blipFill>
+          <a:blip>
+            <a:extLst>
+              <a:ext uri="{96DAC541-7B7A-43D3-8B79-37D633B846F1}">
+                <asvg:svgBlip xmlns:asvg="http://schemas.microsoft.com/office/drawing/2016/SVG/main" r:embed="rId2"/>
+              </a:ext>
+            </a:extLst>
+          </a:blip>
+          <a:stretch>
+            <a:fillRect/>
+          </a:stretch>
+        </p:blipFill>
+        <p:spPr>
+          <a:xfrm>
+            <a:off x="6532704" y="5079655"/>
+            <a:ext cx="253825" cy="253825"/>
+          </a:xfrm>
+          <a:prstGeom prst="rect">
+            <a:avLst/>
+          </a:prstGeom>
+        </p:spPr>
+      </p:pic>
+      <p:pic>
+        <p:nvPicPr>
+          <p:cNvPr id="8" name="Graphic 7" descr="Snail with solid fill">
+            <a:extLst>
+              <a:ext uri="{FF2B5EF4-FFF2-40B4-BE49-F238E27FC236}">
+                <a16:creationId xmlns:a16="http://schemas.microsoft.com/office/drawing/2014/main" id="{F210DEC2-D720-F750-B1E7-2D733100ABD9}"/>
+              </a:ext>
+            </a:extLst>
+          </p:cNvPr>
+          <p:cNvPicPr>
+            <a:picLocks noChangeAspect="1"/>
+          </p:cNvPicPr>
+          <p:nvPr/>
+        </p:nvPicPr>
+        <p:blipFill>
+          <a:blip>
+            <a:extLst>
+              <a:ext uri="{96DAC541-7B7A-43D3-8B79-37D633B846F1}">
+                <asvg:svgBlip xmlns:asvg="http://schemas.microsoft.com/office/drawing/2016/SVG/main" r:embed="rId3"/>
+              </a:ext>
+            </a:extLst>
+          </a:blip>
+          <a:stretch>
+            <a:fillRect/>
+          </a:stretch>
+        </p:blipFill>
+        <p:spPr>
+          <a:xfrm>
+            <a:off x="7365646" y="5083070"/>
+            <a:ext cx="246993" cy="246993"/>
+          </a:xfrm>
+          <a:prstGeom prst="rect">
+            <a:avLst/>
+          </a:prstGeom>
+        </p:spPr>
+      </p:pic>
+      <p:pic>
+        <p:nvPicPr>
+          <p:cNvPr id="10" name="Graphic 9" descr="Toy Train with solid fill">
+            <a:extLst>
+              <a:ext uri="{FF2B5EF4-FFF2-40B4-BE49-F238E27FC236}">
+                <a16:creationId xmlns:a16="http://schemas.microsoft.com/office/drawing/2014/main" id="{41BFCC3B-584D-D8F0-B30B-F2EAAD0AA1F5}"/>
+              </a:ext>
+            </a:extLst>
+          </p:cNvPr>
+          <p:cNvPicPr>
+            <a:picLocks noChangeAspect="1"/>
+          </p:cNvPicPr>
+          <p:nvPr/>
+        </p:nvPicPr>
+        <p:blipFill>
+          <a:blip>
+            <a:extLst>
+              <a:ext uri="{96DAC541-7B7A-43D3-8B79-37D633B846F1}">
+                <asvg:svgBlip xmlns:asvg="http://schemas.microsoft.com/office/drawing/2016/SVG/main" r:embed="rId4"/>
+              </a:ext>
+            </a:extLst>
+          </a:blip>
+          <a:stretch>
+            <a:fillRect/>
+          </a:stretch>
+        </p:blipFill>
+        <p:spPr>
+          <a:xfrm>
+            <a:off x="7365646" y="5386293"/>
+            <a:ext cx="297443" cy="297443"/>
+          </a:xfrm>
+          <a:prstGeom prst="rect">
+            <a:avLst/>
+          </a:prstGeom>
+        </p:spPr>
+      </p:pic>
+      <p:pic>
+        <p:nvPicPr>
+          <p:cNvPr id="12" name="Graphic 11" descr="Toy Train with solid fill">
+            <a:extLst>
+              <a:ext uri="{FF2B5EF4-FFF2-40B4-BE49-F238E27FC236}">
+                <a16:creationId xmlns:a16="http://schemas.microsoft.com/office/drawing/2014/main" id="{DADF77C0-B727-7966-FB2B-01F369A15513}"/>
+              </a:ext>
+            </a:extLst>
+          </p:cNvPr>
+          <p:cNvPicPr>
+            <a:picLocks noChangeAspect="1"/>
+          </p:cNvPicPr>
+          <p:nvPr/>
+        </p:nvPicPr>
+        <p:blipFill>
+          <a:blip>
+            <a:extLst>
+              <a:ext uri="{96DAC541-7B7A-43D3-8B79-37D633B846F1}">
+                <asvg:svgBlip xmlns:asvg="http://schemas.microsoft.com/office/drawing/2016/SVG/main" r:embed="rId4"/>
+              </a:ext>
+            </a:extLst>
+          </a:blip>
+          <a:stretch>
+            <a:fillRect/>
+          </a:stretch>
+        </p:blipFill>
+        <p:spPr>
+          <a:xfrm>
+            <a:off x="6532704" y="5386293"/>
+            <a:ext cx="297443" cy="297443"/>
+          </a:xfrm>
+          <a:prstGeom prst="rect">
+            <a:avLst/>
+          </a:prstGeom>
+        </p:spPr>
+      </p:pic>
     </p:spTree>
     <p:extLst>
       <p:ext uri="{BB962C8B-B14F-4D97-AF65-F5344CB8AC3E}">
-        <p14:creationId xmlns:p14="http://schemas.microsoft.com/office/powerpoint/2010/main" val="1797426774"/>
+        <p14:creationId xmlns:p14="http://schemas.microsoft.com/office/powerpoint/2010/main" val="208294018"/>
       </p:ext>
     </p:extLst>
   </p:cSld>
   <p:clrMapOvr>
     <a:masterClrMapping/>
   </p:clrMapOvr>
-  <p:timing>
-    <p:tnLst>
-      <p:par>
-        <p:cTn id="1" dur="indefinite" restart="never" nodeType="tmRoot">
-          <p:childTnLst>
-            <p:seq concurrent="1" nextAc="seek">
-              <p:cTn id="2" dur="indefinite" nodeType="mainSeq">
-                <p:childTnLst>
-                  <p:par>
-                    <p:cTn id="3" fill="hold">
-                      <p:stCondLst>
-                        <p:cond delay="indefinite"/>
-                        <p:cond evt="onBegin" delay="0">
-                          <p:tn val="2"/>
-                        </p:cond>
-                      </p:stCondLst>
-                      <p:childTnLst>
-                        <p:par>
-                          <p:cTn id="4" fill="hold">
-                            <p:stCondLst>
-                              <p:cond delay="0"/>
-                            </p:stCondLst>
-                            <p:childTnLst>
-                              <p:par>
-                                <p:cTn id="5" presetID="1" presetClass="entr" presetSubtype="0" fill="hold" grpId="0" nodeType="withEffect">
-                                  <p:stCondLst>
-                                    <p:cond delay="0"/>
-                                  </p:stCondLst>
-                                  <p:childTnLst>
-                                    <p:set>
-                                      <p:cBhvr>
-                                        <p:cTn id="6" dur="1" fill="hold">
-                                          <p:stCondLst>
-                                            <p:cond delay="0"/>
-                                          </p:stCondLst>
-                                        </p:cTn>
-                                        <p:tgtEl>
-                                          <p:spTgt spid="3">
-                                            <p:txEl>
-                                              <p:pRg st="0" end="0"/>
-                                            </p:txEl>
-                                          </p:spTgt>
-                                        </p:tgtEl>
-                                        <p:attrNameLst>
-                                          <p:attrName>style.visibility</p:attrName>
-                                        </p:attrNameLst>
-                                      </p:cBhvr>
-                                      <p:to>
-                                        <p:strVal val="visible"/>
-                                      </p:to>
-                                    </p:set>
-                                  </p:childTnLst>
-                                </p:cTn>
-                              </p:par>
-                            </p:childTnLst>
-                          </p:cTn>
-                        </p:par>
-                      </p:childTnLst>
-                    </p:cTn>
-                  </p:par>
-                </p:childTnLst>
-              </p:cTn>
-              <p:prevCondLst>
-                <p:cond evt="onPrev" delay="0">
-                  <p:tgtEl>
-                    <p:sldTgt/>
-                  </p:tgtEl>
-                </p:cond>
-              </p:prevCondLst>
-              <p:nextCondLst>
-                <p:cond evt="onNext" delay="0">
-                  <p:tgtEl>
-                    <p:sldTgt/>
-                  </p:tgtEl>
-                </p:cond>
-              </p:nextCondLst>
-            </p:seq>
-          </p:childTnLst>
-        </p:cTn>
-      </p:par>
-    </p:tnLst>
-    <p:bldLst>
-      <p:bldP spid="3" grpId="0" uiExpand="1" build="p"/>
-    </p:bldLst>
-  </p:timing>
 </p:sld>
 </file>
 
@@ -9593,7 +10144,13 @@
       </p:grpSpPr>
       <p:sp>
         <p:nvSpPr>
-          <p:cNvPr id="2" name="Title 1"/>
+          <p:cNvPr id="2" name="Title 1">
+            <a:extLst>
+              <a:ext uri="{FF2B5EF4-FFF2-40B4-BE49-F238E27FC236}">
+                <a16:creationId xmlns:a16="http://schemas.microsoft.com/office/drawing/2014/main" id="{2348527E-0A68-A2B7-3562-5CDB40FCF029}"/>
+              </a:ext>
+            </a:extLst>
+          </p:cNvPr>
           <p:cNvSpPr>
             <a:spLocks noGrp="1"/>
           </p:cNvSpPr>
@@ -9608,14 +10165,21 @@
           <a:p>
             <a:r>
               <a:rPr lang="en-US" dirty="0"/>
-              <a:t>Further reading</a:t>
-            </a:r>
-          </a:p>
-        </p:txBody>
-      </p:sp>
-      <p:sp>
-        <p:nvSpPr>
-          <p:cNvPr id="3" name="Content Placeholder 2"/>
+              <a:t>Fully Sharded Data Parallelism (FSDP)</a:t>
+            </a:r>
+            <a:endParaRPr lang="LID4096" dirty="0"/>
+          </a:p>
+        </p:txBody>
+      </p:sp>
+      <p:sp>
+        <p:nvSpPr>
+          <p:cNvPr id="3" name="Content Placeholder 2">
+            <a:extLst>
+              <a:ext uri="{FF2B5EF4-FFF2-40B4-BE49-F238E27FC236}">
+                <a16:creationId xmlns:a16="http://schemas.microsoft.com/office/drawing/2014/main" id="{40BF5FE2-ED62-9CFD-9027-7EB9E03894BB}"/>
+              </a:ext>
+            </a:extLst>
+          </p:cNvPr>
           <p:cNvSpPr>
             <a:spLocks noGrp="1"/>
           </p:cNvSpPr>
@@ -9626,17 +10190,95 @@
         <p:spPr/>
         <p:txBody>
           <a:bodyPr>
-            <a:normAutofit/>
+            <a:normAutofit lnSpcReduction="10000"/>
           </a:bodyPr>
           <a:lstStyle/>
           <a:p>
-            <a:endParaRPr lang="" dirty="0"/>
-          </a:p>
-        </p:txBody>
-      </p:sp>
-      <p:sp>
-        <p:nvSpPr>
-          <p:cNvPr id="4" name="Slide Number Placeholder 3"/>
+            <a:r>
+              <a:rPr lang="en-US" dirty="0"/>
+              <a:t>Fully sharded, each GPU holds part of</a:t>
+            </a:r>
+          </a:p>
+          <a:p>
+            <a:pPr lvl="1"/>
+            <a:r>
+              <a:rPr lang="en-US" dirty="0"/>
+              <a:t>Parameters</a:t>
+            </a:r>
+          </a:p>
+          <a:p>
+            <a:pPr lvl="1"/>
+            <a:r>
+              <a:rPr lang="en-US" dirty="0"/>
+              <a:t>Gradients</a:t>
+            </a:r>
+          </a:p>
+          <a:p>
+            <a:pPr lvl="1"/>
+            <a:r>
+              <a:rPr lang="en-US" dirty="0"/>
+              <a:t>Optimizer state</a:t>
+            </a:r>
+          </a:p>
+          <a:p>
+            <a:r>
+              <a:rPr lang="en-US" dirty="0"/>
+              <a:t>Data parallel, each GPU trains on its own data</a:t>
+            </a:r>
+          </a:p>
+          <a:p>
+            <a:r>
+              <a:rPr lang="en-US" dirty="0"/>
+              <a:t>Aggregate when needed</a:t>
+            </a:r>
+          </a:p>
+          <a:p>
+            <a:pPr lvl="1"/>
+            <a:r>
+              <a:rPr lang="en-US" dirty="0"/>
+              <a:t>Forward pass</a:t>
+            </a:r>
+          </a:p>
+          <a:p>
+            <a:pPr lvl="2"/>
+            <a:r>
+              <a:rPr lang="en-US" dirty="0"/>
+              <a:t>Parameters</a:t>
+            </a:r>
+          </a:p>
+          <a:p>
+            <a:pPr lvl="1"/>
+            <a:r>
+              <a:rPr lang="en-US" dirty="0"/>
+              <a:t>Backward pass</a:t>
+            </a:r>
+          </a:p>
+          <a:p>
+            <a:pPr lvl="2"/>
+            <a:r>
+              <a:rPr lang="en-US" dirty="0"/>
+              <a:t>Gradients</a:t>
+            </a:r>
+          </a:p>
+          <a:p>
+            <a:pPr lvl="1"/>
+            <a:r>
+              <a:rPr lang="en-US" dirty="0"/>
+              <a:t>Optimize</a:t>
+            </a:r>
+            <a:endParaRPr lang="LID4096" dirty="0"/>
+          </a:p>
+        </p:txBody>
+      </p:sp>
+      <p:sp>
+        <p:nvSpPr>
+          <p:cNvPr id="4" name="Slide Number Placeholder 3">
+            <a:extLst>
+              <a:ext uri="{FF2B5EF4-FFF2-40B4-BE49-F238E27FC236}">
+                <a16:creationId xmlns:a16="http://schemas.microsoft.com/office/drawing/2014/main" id="{C5C3AF90-762D-2D81-0AE7-2BAEC8D92E2B}"/>
+              </a:ext>
+            </a:extLst>
+          </p:cNvPr>
           <p:cNvSpPr>
             <a:spLocks noGrp="1"/>
           </p:cNvSpPr>
@@ -9660,7 +10302,7 @@
     </p:spTree>
     <p:extLst>
       <p:ext uri="{BB962C8B-B14F-4D97-AF65-F5344CB8AC3E}">
-        <p14:creationId xmlns:p14="http://schemas.microsoft.com/office/powerpoint/2010/main" val="3443787918"/>
+        <p14:creationId xmlns:p14="http://schemas.microsoft.com/office/powerpoint/2010/main" val="963192075"/>
       </p:ext>
     </p:extLst>
   </p:cSld>

</xml_diff>